<commit_message>
Wees 6 and the small cap tier v0.6.0-v0.8.1
23 Oct — Claude API key staged in key.txt inside the project folder, committed locally on 19 Oct (32ffd7b), never pushed; GitHub push protection refused the push. Key rotated; the commit folded away; staging files now live outside the repo and are ignored.
</commit_message>
<xml_diff>
--- a/docs/lessons/week-05-the-graham-checklist.pptx
+++ b/docs/lessons/week-05-the-graham-checklist.pptx
@@ -1570,7 +1570,7 @@
           <a:p>
             <a:r>
               <a:rPr lang="en-US" dirty="0"/>
-              <a:t>20 min. Give each pair a household-name failure: a tech giant, a carmaker, an aircraft maker, a bank. Hand them the two modern frictions on the next slide when they get stuck.</a:t>
+              <a:t>20 min. If nothing survives (the first live run, 13 Oct 2026, had no survivors and no near misses), pairs take the highest scorers instead — on that run Nvidia at 5/7, failing only the two price tests — plus a household-name failure: a tech giant, a carmaker, an aircraft maker, a bank. The ready-made material is the eight-company table in docs/lessons/week-05-reading-the-screen.md (point 4). Hand them the modern frictions on the next slide when they get stuck.</a:t>
             </a:r>
             <a:endParaRPr lang="en-US" dirty="0"/>
           </a:p>
@@ -9197,7 +9197,7 @@
                 <a:ea typeface="Courier New" pitchFamily="34" charset="-122"/>
                 <a:cs typeface="Courier New" pitchFamily="34" charset="-120"/>
               </a:rPr>
-              <a:t>0:55 — PAIRS: ONE SURVIVOR, ONE FAMOUS FAILURE</a:t>
+              <a:t>0:55 — PAIRS: THE CLOSEST, AND ONE FAMOUS FAILURE</a:t>
             </a:r>
             <a:endParaRPr lang="en-US" sz="1200" dirty="0"/>
           </a:p>
@@ -9595,24 +9595,24 @@
         </p:nvSpPr>
         <p:spPr>
           <a:xfrm>
-            <a:off x="822960" y="5029200"/>
-            <a:ext cx="10515600" cy="640080"/>
-          </a:xfrm>
-          <a:prstGeom prst="rect">
-            <a:avLst/>
-          </a:prstGeom>
-          <a:noFill/>
-          <a:ln/>
-        </p:spPr>
-        <p:txBody>
-          <a:bodyPr wrap="square" lIns="0" tIns="0" rIns="0" bIns="0" rtlCol="0" anchor="ctr"/>
-          <a:lstStyle/>
-          <a:p>
-            <a:pPr indent="0" marL="0">
-              <a:buNone/>
-            </a:pPr>
-            <a:r>
-              <a:rPr lang="en-US" sz="1800" i="1" dirty="0">
+            <a:off x="822960" y="4892040"/>
+            <a:ext cx="10515600" cy="914400"/>
+          </a:xfrm>
+          <a:prstGeom prst="rect">
+            <a:avLst/>
+          </a:prstGeom>
+          <a:noFill/>
+          <a:ln/>
+        </p:spPr>
+        <p:txBody>
+          <a:bodyPr wrap="square" lIns="0" tIns="0" rIns="0" bIns="0" rtlCol="0" anchor="ctr"/>
+          <a:lstStyle/>
+          <a:p>
+            <a:pPr indent="0" marL="0">
+              <a:buNone/>
+            </a:pPr>
+            <a:r>
+              <a:rPr lang="en-US" sz="1600" i="1" dirty="0">
                 <a:solidFill>
                   <a:srgbClr val="3E6B54"/>
                 </a:solidFill>
@@ -9620,9 +9620,9 @@
                 <a:ea typeface="Century Schoolbook" pitchFamily="34" charset="-122"/>
                 <a:cs typeface="Century Schoolbook" pitchFamily="34" charset="-120"/>
               </a:rPr>
-              <a:t>One sentence per pair. The course takes no side — the skill is arguing from the books, not the headlines.</a:t>
-            </a:r>
-            <a:endParaRPr lang="en-US" sz="1800" dirty="0"/>
+              <a:t>Each pair takes the best scorer on the screen — a survivor, a near miss, or if none, the highest score — plus one famous failure. One sentence per pair; the course takes no side.</a:t>
+            </a:r>
+            <a:endParaRPr lang="en-US" sz="1600" dirty="0"/>
           </a:p>
         </p:txBody>
       </p:sp>

</xml_diff>

<commit_message>
v0.8.2: Phase 2 review implemented — raw ratios, dividend cadence, readings on the page, quote cap; the record applied
</commit_message>
<xml_diff>
--- a/docs/lessons/week-05-the-graham-checklist.pptx
+++ b/docs/lessons/week-05-the-graham-checklist.pptx
@@ -1951,6 +1951,45 @@
         </p:nvSpPr>
         <p:spPr>
           <a:xfrm>
+            <a:off x="548640" y="6419088"/>
+            <a:ext cx="3108960" cy="274320"/>
+          </a:xfrm>
+          <a:prstGeom prst="rect">
+            <a:avLst/>
+          </a:prstGeom>
+          <a:noFill/>
+          <a:ln/>
+        </p:spPr>
+        <p:txBody>
+          <a:bodyPr wrap="square" lIns="0" tIns="0" rIns="0" bIns="0" rtlCol="0" anchor="ctr"/>
+          <a:lstStyle/>
+          <a:p>
+            <a:pPr indent="0" marL="0">
+              <a:buNone/>
+            </a:pPr>
+            <a:r>
+              <a:rPr lang="en-US" sz="900" dirty="0">
+                <a:solidFill>
+                  <a:srgbClr val="A9B6AE"/>
+                </a:solidFill>
+                <a:latin typeface="Calibri" pitchFamily="34" charset="0"/>
+                <a:ea typeface="Calibri" pitchFamily="34" charset="-122"/>
+                <a:cs typeface="Calibri" pitchFamily="34" charset="-120"/>
+              </a:rPr>
+              <a:t>Education, not advice.</a:t>
+            </a:r>
+            <a:endParaRPr lang="en-US" sz="900" dirty="0"/>
+          </a:p>
+        </p:txBody>
+      </p:sp>
+      <p:sp>
+        <p:nvSpPr>
+          <p:cNvPr id="3" name="Text 1"/>
+          <p:cNvSpPr txBox="1"/>
+          <p:nvPr/>
+        </p:nvSpPr>
+        <p:spPr>
+          <a:xfrm>
             <a:off x="822960" y="1051560"/>
             <a:ext cx="10515600" cy="365760"/>
           </a:xfrm>
@@ -1984,7 +2023,7 @@
       </p:sp>
       <p:sp>
         <p:nvSpPr>
-          <p:cNvPr id="3" name="Text 1"/>
+          <p:cNvPr id="4" name="Text 2"/>
           <p:cNvSpPr txBox="1"/>
           <p:nvPr/>
         </p:nvSpPr>
@@ -2023,7 +2062,7 @@
       </p:sp>
       <p:sp>
         <p:nvSpPr>
-          <p:cNvPr id="4" name="Text 2"/>
+          <p:cNvPr id="5" name="Text 3"/>
           <p:cNvSpPr txBox="1"/>
           <p:nvPr/>
         </p:nvSpPr>
@@ -2065,7 +2104,7 @@
       </p:sp>
       <p:sp>
         <p:nvSpPr>
-          <p:cNvPr id="5" name="Text 3"/>
+          <p:cNvPr id="6" name="Text 4"/>
           <p:cNvSpPr txBox="1"/>
           <p:nvPr/>
         </p:nvSpPr>
@@ -2108,7 +2147,7 @@
       </p:sp>
       <p:sp>
         <p:nvSpPr>
-          <p:cNvPr id="6" name="Text 4"/>
+          <p:cNvPr id="7" name="Text 5"/>
           <p:cNvSpPr txBox="1"/>
           <p:nvPr/>
         </p:nvSpPr>
@@ -2185,6 +2224,45 @@
         </p:nvSpPr>
         <p:spPr>
           <a:xfrm>
+            <a:off x="548640" y="6419088"/>
+            <a:ext cx="3108960" cy="274320"/>
+          </a:xfrm>
+          <a:prstGeom prst="rect">
+            <a:avLst/>
+          </a:prstGeom>
+          <a:noFill/>
+          <a:ln/>
+        </p:spPr>
+        <p:txBody>
+          <a:bodyPr wrap="square" lIns="0" tIns="0" rIns="0" bIns="0" rtlCol="0" anchor="ctr"/>
+          <a:lstStyle/>
+          <a:p>
+            <a:pPr indent="0" marL="0">
+              <a:buNone/>
+            </a:pPr>
+            <a:r>
+              <a:rPr lang="en-US" sz="900" dirty="0">
+                <a:solidFill>
+                  <a:srgbClr val="6B7A72"/>
+                </a:solidFill>
+                <a:latin typeface="Calibri" pitchFamily="34" charset="0"/>
+                <a:ea typeface="Calibri" pitchFamily="34" charset="-122"/>
+                <a:cs typeface="Calibri" pitchFamily="34" charset="-120"/>
+              </a:rPr>
+              <a:t>Education, not advice.</a:t>
+            </a:r>
+            <a:endParaRPr lang="en-US" sz="900" dirty="0"/>
+          </a:p>
+        </p:txBody>
+      </p:sp>
+      <p:sp>
+        <p:nvSpPr>
+          <p:cNvPr id="3" name="Text 1"/>
+          <p:cNvSpPr txBox="1"/>
+          <p:nvPr/>
+        </p:nvSpPr>
+        <p:spPr>
+          <a:xfrm>
             <a:off x="822960" y="502920"/>
             <a:ext cx="9144000" cy="320040"/>
           </a:xfrm>
@@ -2218,7 +2296,7 @@
       </p:sp>
       <p:sp>
         <p:nvSpPr>
-          <p:cNvPr id="3" name="Text 1"/>
+          <p:cNvPr id="4" name="Text 2"/>
           <p:cNvSpPr txBox="1"/>
           <p:nvPr/>
         </p:nvSpPr>
@@ -2257,7 +2335,7 @@
       </p:sp>
       <p:sp>
         <p:nvSpPr>
-          <p:cNvPr id="4" name="Shape 2"/>
+          <p:cNvPr id="5" name="Shape 3"/>
           <p:cNvSpPr/>
           <p:nvPr/>
         </p:nvSpPr>
@@ -2291,7 +2369,7 @@
       </p:sp>
       <p:sp>
         <p:nvSpPr>
-          <p:cNvPr id="5" name="Text 3"/>
+          <p:cNvPr id="6" name="Text 4"/>
           <p:cNvSpPr txBox="1"/>
           <p:nvPr/>
         </p:nvSpPr>
@@ -2330,7 +2408,7 @@
       </p:sp>
       <p:sp>
         <p:nvSpPr>
-          <p:cNvPr id="6" name="Text 4"/>
+          <p:cNvPr id="7" name="Text 5"/>
           <p:cNvSpPr txBox="1"/>
           <p:nvPr/>
         </p:nvSpPr>
@@ -2372,7 +2450,7 @@
       </p:sp>
       <p:sp>
         <p:nvSpPr>
-          <p:cNvPr id="7" name="Shape 5"/>
+          <p:cNvPr id="8" name="Shape 6"/>
           <p:cNvSpPr/>
           <p:nvPr/>
         </p:nvSpPr>
@@ -2406,7 +2484,7 @@
       </p:sp>
       <p:sp>
         <p:nvSpPr>
-          <p:cNvPr id="8" name="Text 6"/>
+          <p:cNvPr id="9" name="Text 7"/>
           <p:cNvSpPr txBox="1"/>
           <p:nvPr/>
         </p:nvSpPr>
@@ -2445,7 +2523,7 @@
       </p:sp>
       <p:sp>
         <p:nvSpPr>
-          <p:cNvPr id="9" name="Text 7"/>
+          <p:cNvPr id="10" name="Text 8"/>
           <p:cNvSpPr txBox="1"/>
           <p:nvPr/>
         </p:nvSpPr>
@@ -2487,7 +2565,7 @@
       </p:sp>
       <p:sp>
         <p:nvSpPr>
-          <p:cNvPr id="10" name="Shape 8"/>
+          <p:cNvPr id="11" name="Shape 9"/>
           <p:cNvSpPr/>
           <p:nvPr/>
         </p:nvSpPr>
@@ -2521,7 +2599,7 @@
       </p:sp>
       <p:sp>
         <p:nvSpPr>
-          <p:cNvPr id="11" name="Text 9"/>
+          <p:cNvPr id="12" name="Text 10"/>
           <p:cNvSpPr txBox="1"/>
           <p:nvPr/>
         </p:nvSpPr>
@@ -2560,7 +2638,7 @@
       </p:sp>
       <p:sp>
         <p:nvSpPr>
-          <p:cNvPr id="12" name="Text 10"/>
+          <p:cNvPr id="13" name="Text 11"/>
           <p:cNvSpPr txBox="1"/>
           <p:nvPr/>
         </p:nvSpPr>
@@ -2597,45 +2675,6 @@
               <a:t>Graham's strength test is written for industrial companies; for banks he applied only the price tests. So test 2 is skipped, not failed — and they're scored out of six.</a:t>
             </a:r>
             <a:endParaRPr lang="en-US" sz="1350" dirty="0"/>
-          </a:p>
-        </p:txBody>
-      </p:sp>
-      <p:sp>
-        <p:nvSpPr>
-          <p:cNvPr id="13" name="Text 11"/>
-          <p:cNvSpPr txBox="1"/>
-          <p:nvPr/>
-        </p:nvSpPr>
-        <p:spPr>
-          <a:xfrm>
-            <a:off x="548640" y="6419088"/>
-            <a:ext cx="3108960" cy="274320"/>
-          </a:xfrm>
-          <a:prstGeom prst="rect">
-            <a:avLst/>
-          </a:prstGeom>
-          <a:noFill/>
-          <a:ln/>
-        </p:spPr>
-        <p:txBody>
-          <a:bodyPr wrap="square" lIns="0" tIns="0" rIns="0" bIns="0" rtlCol="0" anchor="ctr"/>
-          <a:lstStyle/>
-          <a:p>
-            <a:pPr indent="0" marL="0">
-              <a:buNone/>
-            </a:pPr>
-            <a:r>
-              <a:rPr lang="en-US" sz="900" dirty="0">
-                <a:solidFill>
-                  <a:srgbClr val="6B7A72"/>
-                </a:solidFill>
-                <a:latin typeface="Calibri" pitchFamily="34" charset="0"/>
-                <a:ea typeface="Calibri" pitchFamily="34" charset="-122"/>
-                <a:cs typeface="Calibri" pitchFamily="34" charset="-120"/>
-              </a:rPr>
-              <a:t>Education, not advice.</a:t>
-            </a:r>
-            <a:endParaRPr lang="en-US" sz="900" dirty="0"/>
           </a:p>
         </p:txBody>
       </p:sp>
@@ -2718,6 +2757,45 @@
         </p:nvSpPr>
         <p:spPr>
           <a:xfrm>
+            <a:off x="548640" y="6419088"/>
+            <a:ext cx="3108960" cy="274320"/>
+          </a:xfrm>
+          <a:prstGeom prst="rect">
+            <a:avLst/>
+          </a:prstGeom>
+          <a:noFill/>
+          <a:ln/>
+        </p:spPr>
+        <p:txBody>
+          <a:bodyPr wrap="square" lIns="0" tIns="0" rIns="0" bIns="0" rtlCol="0" anchor="ctr"/>
+          <a:lstStyle/>
+          <a:p>
+            <a:pPr indent="0" marL="0">
+              <a:buNone/>
+            </a:pPr>
+            <a:r>
+              <a:rPr lang="en-US" sz="900" dirty="0">
+                <a:solidFill>
+                  <a:srgbClr val="6B7A72"/>
+                </a:solidFill>
+                <a:latin typeface="Calibri" pitchFamily="34" charset="0"/>
+                <a:ea typeface="Calibri" pitchFamily="34" charset="-122"/>
+                <a:cs typeface="Calibri" pitchFamily="34" charset="-120"/>
+              </a:rPr>
+              <a:t>Education, not advice.</a:t>
+            </a:r>
+            <a:endParaRPr lang="en-US" sz="900" dirty="0"/>
+          </a:p>
+        </p:txBody>
+      </p:sp>
+      <p:sp>
+        <p:nvSpPr>
+          <p:cNvPr id="3" name="Text 1"/>
+          <p:cNvSpPr txBox="1"/>
+          <p:nvPr/>
+        </p:nvSpPr>
+        <p:spPr>
+          <a:xfrm>
             <a:off x="822960" y="502920"/>
             <a:ext cx="9144000" cy="320040"/>
           </a:xfrm>
@@ -2751,7 +2829,7 @@
       </p:sp>
       <p:sp>
         <p:nvSpPr>
-          <p:cNvPr id="3" name="Text 1"/>
+          <p:cNvPr id="4" name="Text 2"/>
           <p:cNvSpPr txBox="1"/>
           <p:nvPr/>
         </p:nvSpPr>
@@ -2790,7 +2868,7 @@
       </p:sp>
       <p:sp>
         <p:nvSpPr>
-          <p:cNvPr id="4" name="Shape 2"/>
+          <p:cNvPr id="5" name="Shape 3"/>
           <p:cNvSpPr/>
           <p:nvPr/>
         </p:nvSpPr>
@@ -2824,7 +2902,7 @@
       </p:sp>
       <p:sp>
         <p:nvSpPr>
-          <p:cNvPr id="5" name="Text 3"/>
+          <p:cNvPr id="6" name="Text 4"/>
           <p:cNvSpPr txBox="1"/>
           <p:nvPr/>
         </p:nvSpPr>
@@ -2863,7 +2941,7 @@
       </p:sp>
       <p:sp>
         <p:nvSpPr>
-          <p:cNvPr id="6" name="Text 4"/>
+          <p:cNvPr id="7" name="Text 5"/>
           <p:cNvSpPr txBox="1"/>
           <p:nvPr/>
         </p:nvSpPr>
@@ -2905,7 +2983,7 @@
       </p:sp>
       <p:sp>
         <p:nvSpPr>
-          <p:cNvPr id="7" name="Shape 5"/>
+          <p:cNvPr id="8" name="Shape 6"/>
           <p:cNvSpPr/>
           <p:nvPr/>
         </p:nvSpPr>
@@ -2939,7 +3017,7 @@
       </p:sp>
       <p:sp>
         <p:nvSpPr>
-          <p:cNvPr id="8" name="Text 6"/>
+          <p:cNvPr id="9" name="Text 7"/>
           <p:cNvSpPr txBox="1"/>
           <p:nvPr/>
         </p:nvSpPr>
@@ -2978,7 +3056,7 @@
       </p:sp>
       <p:sp>
         <p:nvSpPr>
-          <p:cNvPr id="9" name="Text 7"/>
+          <p:cNvPr id="10" name="Text 8"/>
           <p:cNvSpPr txBox="1"/>
           <p:nvPr/>
         </p:nvSpPr>
@@ -3020,7 +3098,7 @@
       </p:sp>
       <p:sp>
         <p:nvSpPr>
-          <p:cNvPr id="10" name="Shape 8"/>
+          <p:cNvPr id="11" name="Shape 9"/>
           <p:cNvSpPr/>
           <p:nvPr/>
         </p:nvSpPr>
@@ -3054,7 +3132,7 @@
       </p:sp>
       <p:sp>
         <p:nvSpPr>
-          <p:cNvPr id="11" name="Text 9"/>
+          <p:cNvPr id="12" name="Text 10"/>
           <p:cNvSpPr txBox="1"/>
           <p:nvPr/>
         </p:nvSpPr>
@@ -3093,7 +3171,7 @@
       </p:sp>
       <p:sp>
         <p:nvSpPr>
-          <p:cNvPr id="12" name="Text 10"/>
+          <p:cNvPr id="13" name="Text 11"/>
           <p:cNvSpPr txBox="1"/>
           <p:nvPr/>
         </p:nvSpPr>
@@ -3135,7 +3213,7 @@
       </p:sp>
       <p:sp>
         <p:nvSpPr>
-          <p:cNvPr id="13" name="Shape 11"/>
+          <p:cNvPr id="14" name="Shape 12"/>
           <p:cNvSpPr/>
           <p:nvPr/>
         </p:nvSpPr>
@@ -3169,7 +3247,7 @@
       </p:sp>
       <p:sp>
         <p:nvSpPr>
-          <p:cNvPr id="14" name="Text 12"/>
+          <p:cNvPr id="15" name="Text 13"/>
           <p:cNvSpPr txBox="1"/>
           <p:nvPr/>
         </p:nvSpPr>
@@ -3208,7 +3286,7 @@
       </p:sp>
       <p:sp>
         <p:nvSpPr>
-          <p:cNvPr id="15" name="Text 13"/>
+          <p:cNvPr id="16" name="Text 14"/>
           <p:cNvSpPr txBox="1"/>
           <p:nvPr/>
         </p:nvSpPr>
@@ -3250,7 +3328,7 @@
       </p:sp>
       <p:sp>
         <p:nvSpPr>
-          <p:cNvPr id="16" name="Text 14"/>
+          <p:cNvPr id="17" name="Text 15"/>
           <p:cNvSpPr txBox="1"/>
           <p:nvPr/>
         </p:nvSpPr>
@@ -3287,45 +3365,6 @@
               <a:t>The screen narrows the list. Reading decides. Zweig's rule: read at least five years of the company's own reports — the books page — or, in his words, you're "too defensive to be buying individual stocks at all."</a:t>
             </a:r>
             <a:endParaRPr lang="en-US" sz="1800" dirty="0"/>
-          </a:p>
-        </p:txBody>
-      </p:sp>
-      <p:sp>
-        <p:nvSpPr>
-          <p:cNvPr id="17" name="Text 15"/>
-          <p:cNvSpPr txBox="1"/>
-          <p:nvPr/>
-        </p:nvSpPr>
-        <p:spPr>
-          <a:xfrm>
-            <a:off x="548640" y="6419088"/>
-            <a:ext cx="3108960" cy="274320"/>
-          </a:xfrm>
-          <a:prstGeom prst="rect">
-            <a:avLst/>
-          </a:prstGeom>
-          <a:noFill/>
-          <a:ln/>
-        </p:spPr>
-        <p:txBody>
-          <a:bodyPr wrap="square" lIns="0" tIns="0" rIns="0" bIns="0" rtlCol="0" anchor="ctr"/>
-          <a:lstStyle/>
-          <a:p>
-            <a:pPr indent="0" marL="0">
-              <a:buNone/>
-            </a:pPr>
-            <a:r>
-              <a:rPr lang="en-US" sz="900" dirty="0">
-                <a:solidFill>
-                  <a:srgbClr val="6B7A72"/>
-                </a:solidFill>
-                <a:latin typeface="Calibri" pitchFamily="34" charset="0"/>
-                <a:ea typeface="Calibri" pitchFamily="34" charset="-122"/>
-                <a:cs typeface="Calibri" pitchFamily="34" charset="-120"/>
-              </a:rPr>
-              <a:t>Education, not advice.</a:t>
-            </a:r>
-            <a:endParaRPr lang="en-US" sz="900" dirty="0"/>
           </a:p>
         </p:txBody>
       </p:sp>
@@ -3369,6 +3408,45 @@
         </p:nvSpPr>
         <p:spPr>
           <a:xfrm>
+            <a:off x="548640" y="6419088"/>
+            <a:ext cx="3108960" cy="274320"/>
+          </a:xfrm>
+          <a:prstGeom prst="rect">
+            <a:avLst/>
+          </a:prstGeom>
+          <a:noFill/>
+          <a:ln/>
+        </p:spPr>
+        <p:txBody>
+          <a:bodyPr wrap="square" lIns="0" tIns="0" rIns="0" bIns="0" rtlCol="0" anchor="ctr"/>
+          <a:lstStyle/>
+          <a:p>
+            <a:pPr indent="0" marL="0">
+              <a:buNone/>
+            </a:pPr>
+            <a:r>
+              <a:rPr lang="en-US" sz="900" dirty="0">
+                <a:solidFill>
+                  <a:srgbClr val="6B7A72"/>
+                </a:solidFill>
+                <a:latin typeface="Calibri" pitchFamily="34" charset="0"/>
+                <a:ea typeface="Calibri" pitchFamily="34" charset="-122"/>
+                <a:cs typeface="Calibri" pitchFamily="34" charset="-120"/>
+              </a:rPr>
+              <a:t>Education, not advice.</a:t>
+            </a:r>
+            <a:endParaRPr lang="en-US" sz="900" dirty="0"/>
+          </a:p>
+        </p:txBody>
+      </p:sp>
+      <p:sp>
+        <p:nvSpPr>
+          <p:cNvPr id="3" name="Text 1"/>
+          <p:cNvSpPr txBox="1"/>
+          <p:nvPr/>
+        </p:nvSpPr>
+        <p:spPr>
+          <a:xfrm>
             <a:off x="822960" y="502920"/>
             <a:ext cx="9144000" cy="320040"/>
           </a:xfrm>
@@ -3402,7 +3480,7 @@
       </p:sp>
       <p:sp>
         <p:nvSpPr>
-          <p:cNvPr id="3" name="Text 1"/>
+          <p:cNvPr id="4" name="Text 2"/>
           <p:cNvSpPr txBox="1"/>
           <p:nvPr/>
         </p:nvSpPr>
@@ -3441,7 +3519,7 @@
       </p:sp>
       <p:sp>
         <p:nvSpPr>
-          <p:cNvPr id="4" name="Shape 2"/>
+          <p:cNvPr id="5" name="Shape 3"/>
           <p:cNvSpPr/>
           <p:nvPr/>
         </p:nvSpPr>
@@ -3475,7 +3553,7 @@
       </p:sp>
       <p:sp>
         <p:nvSpPr>
-          <p:cNvPr id="5" name="Text 3"/>
+          <p:cNvPr id="6" name="Text 4"/>
           <p:cNvSpPr txBox="1"/>
           <p:nvPr/>
         </p:nvSpPr>
@@ -3514,7 +3592,7 @@
       </p:sp>
       <p:sp>
         <p:nvSpPr>
-          <p:cNvPr id="6" name="Text 4"/>
+          <p:cNvPr id="7" name="Text 5"/>
           <p:cNvSpPr txBox="1"/>
           <p:nvPr/>
         </p:nvSpPr>
@@ -3556,7 +3634,7 @@
       </p:sp>
       <p:sp>
         <p:nvSpPr>
-          <p:cNvPr id="7" name="Shape 5"/>
+          <p:cNvPr id="8" name="Shape 6"/>
           <p:cNvSpPr/>
           <p:nvPr/>
         </p:nvSpPr>
@@ -3590,7 +3668,7 @@
       </p:sp>
       <p:sp>
         <p:nvSpPr>
-          <p:cNvPr id="8" name="Text 6"/>
+          <p:cNvPr id="9" name="Text 7"/>
           <p:cNvSpPr txBox="1"/>
           <p:nvPr/>
         </p:nvSpPr>
@@ -3629,7 +3707,7 @@
       </p:sp>
       <p:sp>
         <p:nvSpPr>
-          <p:cNvPr id="9" name="Text 7"/>
+          <p:cNvPr id="10" name="Text 8"/>
           <p:cNvSpPr txBox="1"/>
           <p:nvPr/>
         </p:nvSpPr>
@@ -3671,7 +3749,7 @@
       </p:sp>
       <p:sp>
         <p:nvSpPr>
-          <p:cNvPr id="10" name="Shape 8"/>
+          <p:cNvPr id="11" name="Shape 9"/>
           <p:cNvSpPr/>
           <p:nvPr/>
         </p:nvSpPr>
@@ -3705,7 +3783,7 @@
       </p:sp>
       <p:sp>
         <p:nvSpPr>
-          <p:cNvPr id="11" name="Text 9"/>
+          <p:cNvPr id="12" name="Text 10"/>
           <p:cNvSpPr txBox="1"/>
           <p:nvPr/>
         </p:nvSpPr>
@@ -3744,7 +3822,7 @@
       </p:sp>
       <p:sp>
         <p:nvSpPr>
-          <p:cNvPr id="12" name="Text 10"/>
+          <p:cNvPr id="13" name="Text 11"/>
           <p:cNvSpPr txBox="1"/>
           <p:nvPr/>
         </p:nvSpPr>
@@ -3786,7 +3864,7 @@
       </p:sp>
       <p:sp>
         <p:nvSpPr>
-          <p:cNvPr id="13" name="Text 11"/>
+          <p:cNvPr id="14" name="Text 12"/>
           <p:cNvSpPr txBox="1"/>
           <p:nvPr/>
         </p:nvSpPr>
@@ -3820,45 +3898,6 @@
               <a:t>“We grade decisions, not outcomes.”</a:t>
             </a:r>
             <a:endParaRPr lang="en-US" sz="2400" dirty="0"/>
-          </a:p>
-        </p:txBody>
-      </p:sp>
-      <p:sp>
-        <p:nvSpPr>
-          <p:cNvPr id="14" name="Text 12"/>
-          <p:cNvSpPr txBox="1"/>
-          <p:nvPr/>
-        </p:nvSpPr>
-        <p:spPr>
-          <a:xfrm>
-            <a:off x="548640" y="6419088"/>
-            <a:ext cx="3108960" cy="274320"/>
-          </a:xfrm>
-          <a:prstGeom prst="rect">
-            <a:avLst/>
-          </a:prstGeom>
-          <a:noFill/>
-          <a:ln/>
-        </p:spPr>
-        <p:txBody>
-          <a:bodyPr wrap="square" lIns="0" tIns="0" rIns="0" bIns="0" rtlCol="0" anchor="ctr"/>
-          <a:lstStyle/>
-          <a:p>
-            <a:pPr indent="0" marL="0">
-              <a:buNone/>
-            </a:pPr>
-            <a:r>
-              <a:rPr lang="en-US" sz="900" dirty="0">
-                <a:solidFill>
-                  <a:srgbClr val="6B7A72"/>
-                </a:solidFill>
-                <a:latin typeface="Calibri" pitchFamily="34" charset="0"/>
-                <a:ea typeface="Calibri" pitchFamily="34" charset="-122"/>
-                <a:cs typeface="Calibri" pitchFamily="34" charset="-120"/>
-              </a:rPr>
-              <a:t>Education, not advice.</a:t>
-            </a:r>
-            <a:endParaRPr lang="en-US" sz="900" dirty="0"/>
           </a:p>
         </p:txBody>
       </p:sp>
@@ -3902,6 +3941,45 @@
         </p:nvSpPr>
         <p:spPr>
           <a:xfrm>
+            <a:off x="548640" y="6419088"/>
+            <a:ext cx="3108960" cy="274320"/>
+          </a:xfrm>
+          <a:prstGeom prst="rect">
+            <a:avLst/>
+          </a:prstGeom>
+          <a:noFill/>
+          <a:ln/>
+        </p:spPr>
+        <p:txBody>
+          <a:bodyPr wrap="square" lIns="0" tIns="0" rIns="0" bIns="0" rtlCol="0" anchor="ctr"/>
+          <a:lstStyle/>
+          <a:p>
+            <a:pPr indent="0" marL="0">
+              <a:buNone/>
+            </a:pPr>
+            <a:r>
+              <a:rPr lang="en-US" sz="900" dirty="0">
+                <a:solidFill>
+                  <a:srgbClr val="A9B6AE"/>
+                </a:solidFill>
+                <a:latin typeface="Calibri" pitchFamily="34" charset="0"/>
+                <a:ea typeface="Calibri" pitchFamily="34" charset="-122"/>
+                <a:cs typeface="Calibri" pitchFamily="34" charset="-120"/>
+              </a:rPr>
+              <a:t>Education, not advice.</a:t>
+            </a:r>
+            <a:endParaRPr lang="en-US" sz="900" dirty="0"/>
+          </a:p>
+        </p:txBody>
+      </p:sp>
+      <p:sp>
+        <p:nvSpPr>
+          <p:cNvPr id="3" name="Text 1"/>
+          <p:cNvSpPr txBox="1"/>
+          <p:nvPr/>
+        </p:nvSpPr>
+        <p:spPr>
+          <a:xfrm>
             <a:off x="822960" y="731520"/>
             <a:ext cx="10058400" cy="365760"/>
           </a:xfrm>
@@ -3935,7 +4013,7 @@
       </p:sp>
       <p:sp>
         <p:nvSpPr>
-          <p:cNvPr id="3" name="Text 1"/>
+          <p:cNvPr id="4" name="Text 2"/>
           <p:cNvSpPr txBox="1"/>
           <p:nvPr/>
         </p:nvSpPr>
@@ -3974,7 +4052,7 @@
       </p:sp>
       <p:sp>
         <p:nvSpPr>
-          <p:cNvPr id="4" name="Text 2"/>
+          <p:cNvPr id="5" name="Text 3"/>
           <p:cNvSpPr txBox="1"/>
           <p:nvPr/>
         </p:nvSpPr>
@@ -4013,7 +4091,7 @@
       </p:sp>
       <p:sp>
         <p:nvSpPr>
-          <p:cNvPr id="5" name="Shape 3"/>
+          <p:cNvPr id="6" name="Shape 4"/>
           <p:cNvSpPr/>
           <p:nvPr/>
         </p:nvSpPr>
@@ -4040,7 +4118,7 @@
       </p:sp>
       <p:sp>
         <p:nvSpPr>
-          <p:cNvPr id="6" name="Text 4"/>
+          <p:cNvPr id="7" name="Text 5"/>
           <p:cNvSpPr txBox="1"/>
           <p:nvPr/>
         </p:nvSpPr>
@@ -4093,7 +4171,7 @@
       </p:sp>
       <p:sp>
         <p:nvSpPr>
-          <p:cNvPr id="7" name="Shape 5"/>
+          <p:cNvPr id="8" name="Shape 6"/>
           <p:cNvSpPr/>
           <p:nvPr/>
         </p:nvSpPr>
@@ -4120,7 +4198,7 @@
       </p:sp>
       <p:sp>
         <p:nvSpPr>
-          <p:cNvPr id="8" name="Text 6"/>
+          <p:cNvPr id="9" name="Text 7"/>
           <p:cNvSpPr txBox="1"/>
           <p:nvPr/>
         </p:nvSpPr>
@@ -4173,7 +4251,7 @@
       </p:sp>
       <p:sp>
         <p:nvSpPr>
-          <p:cNvPr id="9" name="Shape 7"/>
+          <p:cNvPr id="10" name="Shape 8"/>
           <p:cNvSpPr/>
           <p:nvPr/>
         </p:nvSpPr>
@@ -4200,7 +4278,7 @@
       </p:sp>
       <p:sp>
         <p:nvSpPr>
-          <p:cNvPr id="10" name="Text 8"/>
+          <p:cNvPr id="11" name="Text 9"/>
           <p:cNvSpPr txBox="1"/>
           <p:nvPr/>
         </p:nvSpPr>
@@ -4253,7 +4331,7 @@
       </p:sp>
       <p:sp>
         <p:nvSpPr>
-          <p:cNvPr id="11" name="Text 9"/>
+          <p:cNvPr id="12" name="Text 10"/>
           <p:cNvSpPr txBox="1"/>
           <p:nvPr/>
         </p:nvSpPr>
@@ -4330,6 +4408,45 @@
         </p:nvSpPr>
         <p:spPr>
           <a:xfrm>
+            <a:off x="548640" y="6419088"/>
+            <a:ext cx="3108960" cy="274320"/>
+          </a:xfrm>
+          <a:prstGeom prst="rect">
+            <a:avLst/>
+          </a:prstGeom>
+          <a:noFill/>
+          <a:ln/>
+        </p:spPr>
+        <p:txBody>
+          <a:bodyPr wrap="square" lIns="0" tIns="0" rIns="0" bIns="0" rtlCol="0" anchor="ctr"/>
+          <a:lstStyle/>
+          <a:p>
+            <a:pPr indent="0" marL="0">
+              <a:buNone/>
+            </a:pPr>
+            <a:r>
+              <a:rPr lang="en-US" sz="900" dirty="0">
+                <a:solidFill>
+                  <a:srgbClr val="6B7A72"/>
+                </a:solidFill>
+                <a:latin typeface="Calibri" pitchFamily="34" charset="0"/>
+                <a:ea typeface="Calibri" pitchFamily="34" charset="-122"/>
+                <a:cs typeface="Calibri" pitchFamily="34" charset="-120"/>
+              </a:rPr>
+              <a:t>Education, not advice.</a:t>
+            </a:r>
+            <a:endParaRPr lang="en-US" sz="900" dirty="0"/>
+          </a:p>
+        </p:txBody>
+      </p:sp>
+      <p:sp>
+        <p:nvSpPr>
+          <p:cNvPr id="3" name="Text 1"/>
+          <p:cNvSpPr txBox="1"/>
+          <p:nvPr/>
+        </p:nvSpPr>
+        <p:spPr>
+          <a:xfrm>
             <a:off x="822960" y="502920"/>
             <a:ext cx="9144000" cy="320040"/>
           </a:xfrm>
@@ -4363,7 +4480,7 @@
       </p:sp>
       <p:sp>
         <p:nvSpPr>
-          <p:cNvPr id="3" name="Text 1"/>
+          <p:cNvPr id="4" name="Text 2"/>
           <p:cNvSpPr txBox="1"/>
           <p:nvPr/>
         </p:nvSpPr>
@@ -4402,7 +4519,7 @@
       </p:sp>
       <p:sp>
         <p:nvSpPr>
-          <p:cNvPr id="4" name="Shape 2"/>
+          <p:cNvPr id="5" name="Shape 3"/>
           <p:cNvSpPr/>
           <p:nvPr/>
         </p:nvSpPr>
@@ -4436,7 +4553,7 @@
       </p:sp>
       <p:sp>
         <p:nvSpPr>
-          <p:cNvPr id="5" name="Text 3"/>
+          <p:cNvPr id="6" name="Text 4"/>
           <p:cNvSpPr txBox="1"/>
           <p:nvPr/>
         </p:nvSpPr>
@@ -4475,7 +4592,7 @@
       </p:sp>
       <p:sp>
         <p:nvSpPr>
-          <p:cNvPr id="6" name="Text 4"/>
+          <p:cNvPr id="7" name="Text 5"/>
           <p:cNvSpPr txBox="1"/>
           <p:nvPr/>
         </p:nvSpPr>
@@ -4517,7 +4634,7 @@
       </p:sp>
       <p:sp>
         <p:nvSpPr>
-          <p:cNvPr id="7" name="Shape 5"/>
+          <p:cNvPr id="8" name="Shape 6"/>
           <p:cNvSpPr/>
           <p:nvPr/>
         </p:nvSpPr>
@@ -4551,7 +4668,7 @@
       </p:sp>
       <p:sp>
         <p:nvSpPr>
-          <p:cNvPr id="8" name="Text 6"/>
+          <p:cNvPr id="9" name="Text 7"/>
           <p:cNvSpPr txBox="1"/>
           <p:nvPr/>
         </p:nvSpPr>
@@ -4590,7 +4707,7 @@
       </p:sp>
       <p:sp>
         <p:nvSpPr>
-          <p:cNvPr id="9" name="Text 7"/>
+          <p:cNvPr id="10" name="Text 8"/>
           <p:cNvSpPr txBox="1"/>
           <p:nvPr/>
         </p:nvSpPr>
@@ -4632,7 +4749,7 @@
       </p:sp>
       <p:sp>
         <p:nvSpPr>
-          <p:cNvPr id="10" name="Shape 8"/>
+          <p:cNvPr id="11" name="Shape 9"/>
           <p:cNvSpPr/>
           <p:nvPr/>
         </p:nvSpPr>
@@ -4666,7 +4783,7 @@
       </p:sp>
       <p:sp>
         <p:nvSpPr>
-          <p:cNvPr id="11" name="Text 9"/>
+          <p:cNvPr id="12" name="Text 10"/>
           <p:cNvSpPr txBox="1"/>
           <p:nvPr/>
         </p:nvSpPr>
@@ -4705,7 +4822,7 @@
       </p:sp>
       <p:sp>
         <p:nvSpPr>
-          <p:cNvPr id="12" name="Text 10"/>
+          <p:cNvPr id="13" name="Text 11"/>
           <p:cNvSpPr txBox="1"/>
           <p:nvPr/>
         </p:nvSpPr>
@@ -4742,45 +4859,6 @@
               <a:t>One number per table that surprised you on your company's books — and what it asked.</a:t>
             </a:r>
             <a:endParaRPr lang="en-US" sz="1350" dirty="0"/>
-          </a:p>
-        </p:txBody>
-      </p:sp>
-      <p:sp>
-        <p:nvSpPr>
-          <p:cNvPr id="13" name="Text 11"/>
-          <p:cNvSpPr txBox="1"/>
-          <p:nvPr/>
-        </p:nvSpPr>
-        <p:spPr>
-          <a:xfrm>
-            <a:off x="548640" y="6419088"/>
-            <a:ext cx="3108960" cy="274320"/>
-          </a:xfrm>
-          <a:prstGeom prst="rect">
-            <a:avLst/>
-          </a:prstGeom>
-          <a:noFill/>
-          <a:ln/>
-        </p:spPr>
-        <p:txBody>
-          <a:bodyPr wrap="square" lIns="0" tIns="0" rIns="0" bIns="0" rtlCol="0" anchor="ctr"/>
-          <a:lstStyle/>
-          <a:p>
-            <a:pPr indent="0" marL="0">
-              <a:buNone/>
-            </a:pPr>
-            <a:r>
-              <a:rPr lang="en-US" sz="900" dirty="0">
-                <a:solidFill>
-                  <a:srgbClr val="6B7A72"/>
-                </a:solidFill>
-                <a:latin typeface="Calibri" pitchFamily="34" charset="0"/>
-                <a:ea typeface="Calibri" pitchFamily="34" charset="-122"/>
-                <a:cs typeface="Calibri" pitchFamily="34" charset="-120"/>
-              </a:rPr>
-              <a:t>Education, not advice.</a:t>
-            </a:r>
-            <a:endParaRPr lang="en-US" sz="900" dirty="0"/>
           </a:p>
         </p:txBody>
       </p:sp>
@@ -4824,6 +4902,45 @@
         </p:nvSpPr>
         <p:spPr>
           <a:xfrm>
+            <a:off x="548640" y="6419088"/>
+            <a:ext cx="3108960" cy="274320"/>
+          </a:xfrm>
+          <a:prstGeom prst="rect">
+            <a:avLst/>
+          </a:prstGeom>
+          <a:noFill/>
+          <a:ln/>
+        </p:spPr>
+        <p:txBody>
+          <a:bodyPr wrap="square" lIns="0" tIns="0" rIns="0" bIns="0" rtlCol="0" anchor="ctr"/>
+          <a:lstStyle/>
+          <a:p>
+            <a:pPr indent="0" marL="0">
+              <a:buNone/>
+            </a:pPr>
+            <a:r>
+              <a:rPr lang="en-US" sz="900" dirty="0">
+                <a:solidFill>
+                  <a:srgbClr val="6B7A72"/>
+                </a:solidFill>
+                <a:latin typeface="Calibri" pitchFamily="34" charset="0"/>
+                <a:ea typeface="Calibri" pitchFamily="34" charset="-122"/>
+                <a:cs typeface="Calibri" pitchFamily="34" charset="-120"/>
+              </a:rPr>
+              <a:t>Education, not advice.</a:t>
+            </a:r>
+            <a:endParaRPr lang="en-US" sz="900" dirty="0"/>
+          </a:p>
+        </p:txBody>
+      </p:sp>
+      <p:sp>
+        <p:nvSpPr>
+          <p:cNvPr id="3" name="Text 1"/>
+          <p:cNvSpPr txBox="1"/>
+          <p:nvPr/>
+        </p:nvSpPr>
+        <p:spPr>
+          <a:xfrm>
             <a:off x="822960" y="502920"/>
             <a:ext cx="9144000" cy="320040"/>
           </a:xfrm>
@@ -4857,7 +4974,7 @@
       </p:sp>
       <p:sp>
         <p:nvSpPr>
-          <p:cNvPr id="3" name="Text 1"/>
+          <p:cNvPr id="4" name="Text 2"/>
           <p:cNvSpPr txBox="1"/>
           <p:nvPr/>
         </p:nvSpPr>
@@ -4896,7 +5013,7 @@
       </p:sp>
       <p:sp>
         <p:nvSpPr>
-          <p:cNvPr id="4" name="Shape 2"/>
+          <p:cNvPr id="5" name="Shape 3"/>
           <p:cNvSpPr/>
           <p:nvPr/>
         </p:nvSpPr>
@@ -4923,7 +5040,7 @@
       </p:sp>
       <p:sp>
         <p:nvSpPr>
-          <p:cNvPr id="5" name="Text 3"/>
+          <p:cNvPr id="6" name="Text 4"/>
           <p:cNvSpPr txBox="1"/>
           <p:nvPr/>
         </p:nvSpPr>
@@ -4962,7 +5079,7 @@
       </p:sp>
       <p:sp>
         <p:nvSpPr>
-          <p:cNvPr id="6" name="Text 4"/>
+          <p:cNvPr id="7" name="Text 5"/>
           <p:cNvSpPr txBox="1"/>
           <p:nvPr/>
         </p:nvSpPr>
@@ -5124,7 +5241,7 @@
       </p:sp>
       <p:sp>
         <p:nvSpPr>
-          <p:cNvPr id="7" name="Shape 5"/>
+          <p:cNvPr id="8" name="Shape 6"/>
           <p:cNvSpPr/>
           <p:nvPr/>
         </p:nvSpPr>
@@ -5151,7 +5268,7 @@
       </p:sp>
       <p:sp>
         <p:nvSpPr>
-          <p:cNvPr id="8" name="Text 6"/>
+          <p:cNvPr id="9" name="Text 7"/>
           <p:cNvSpPr txBox="1"/>
           <p:nvPr/>
         </p:nvSpPr>
@@ -5190,7 +5307,7 @@
       </p:sp>
       <p:sp>
         <p:nvSpPr>
-          <p:cNvPr id="9" name="Text 7"/>
+          <p:cNvPr id="10" name="Text 8"/>
           <p:cNvSpPr txBox="1"/>
           <p:nvPr/>
         </p:nvSpPr>
@@ -5261,7 +5378,7 @@
       </p:sp>
       <p:sp>
         <p:nvSpPr>
-          <p:cNvPr id="10" name="Text 8"/>
+          <p:cNvPr id="11" name="Text 9"/>
           <p:cNvSpPr txBox="1"/>
           <p:nvPr/>
         </p:nvSpPr>
@@ -5295,45 +5412,6 @@
               <a:t>Every test on tonight's card is a different way of building in that gap.</a:t>
             </a:r>
             <a:endParaRPr lang="en-US" sz="2000" dirty="0"/>
-          </a:p>
-        </p:txBody>
-      </p:sp>
-      <p:sp>
-        <p:nvSpPr>
-          <p:cNvPr id="11" name="Text 9"/>
-          <p:cNvSpPr txBox="1"/>
-          <p:nvPr/>
-        </p:nvSpPr>
-        <p:spPr>
-          <a:xfrm>
-            <a:off x="548640" y="6419088"/>
-            <a:ext cx="3108960" cy="274320"/>
-          </a:xfrm>
-          <a:prstGeom prst="rect">
-            <a:avLst/>
-          </a:prstGeom>
-          <a:noFill/>
-          <a:ln/>
-        </p:spPr>
-        <p:txBody>
-          <a:bodyPr wrap="square" lIns="0" tIns="0" rIns="0" bIns="0" rtlCol="0" anchor="ctr"/>
-          <a:lstStyle/>
-          <a:p>
-            <a:pPr indent="0" marL="0">
-              <a:buNone/>
-            </a:pPr>
-            <a:r>
-              <a:rPr lang="en-US" sz="900" dirty="0">
-                <a:solidFill>
-                  <a:srgbClr val="6B7A72"/>
-                </a:solidFill>
-                <a:latin typeface="Calibri" pitchFamily="34" charset="0"/>
-                <a:ea typeface="Calibri" pitchFamily="34" charset="-122"/>
-                <a:cs typeface="Calibri" pitchFamily="34" charset="-120"/>
-              </a:rPr>
-              <a:t>Education, not advice.</a:t>
-            </a:r>
-            <a:endParaRPr lang="en-US" sz="900" dirty="0"/>
           </a:p>
         </p:txBody>
       </p:sp>
@@ -5416,6 +5494,45 @@
         </p:nvSpPr>
         <p:spPr>
           <a:xfrm>
+            <a:off x="548640" y="6419088"/>
+            <a:ext cx="3108960" cy="274320"/>
+          </a:xfrm>
+          <a:prstGeom prst="rect">
+            <a:avLst/>
+          </a:prstGeom>
+          <a:noFill/>
+          <a:ln/>
+        </p:spPr>
+        <p:txBody>
+          <a:bodyPr wrap="square" lIns="0" tIns="0" rIns="0" bIns="0" rtlCol="0" anchor="ctr"/>
+          <a:lstStyle/>
+          <a:p>
+            <a:pPr indent="0" marL="0">
+              <a:buNone/>
+            </a:pPr>
+            <a:r>
+              <a:rPr lang="en-US" sz="900" dirty="0">
+                <a:solidFill>
+                  <a:srgbClr val="6B7A72"/>
+                </a:solidFill>
+                <a:latin typeface="Calibri" pitchFamily="34" charset="0"/>
+                <a:ea typeface="Calibri" pitchFamily="34" charset="-122"/>
+                <a:cs typeface="Calibri" pitchFamily="34" charset="-120"/>
+              </a:rPr>
+              <a:t>Education, not advice.</a:t>
+            </a:r>
+            <a:endParaRPr lang="en-US" sz="900" dirty="0"/>
+          </a:p>
+        </p:txBody>
+      </p:sp>
+      <p:sp>
+        <p:nvSpPr>
+          <p:cNvPr id="3" name="Text 1"/>
+          <p:cNvSpPr txBox="1"/>
+          <p:nvPr/>
+        </p:nvSpPr>
+        <p:spPr>
+          <a:xfrm>
             <a:off x="822960" y="502920"/>
             <a:ext cx="9144000" cy="320040"/>
           </a:xfrm>
@@ -5449,7 +5566,7 @@
       </p:sp>
       <p:sp>
         <p:nvSpPr>
-          <p:cNvPr id="3" name="Text 1"/>
+          <p:cNvPr id="4" name="Text 2"/>
           <p:cNvSpPr txBox="1"/>
           <p:nvPr/>
         </p:nvSpPr>
@@ -5488,7 +5605,7 @@
       </p:sp>
       <p:sp>
         <p:nvSpPr>
-          <p:cNvPr id="4" name="Shape 2"/>
+          <p:cNvPr id="5" name="Shape 3"/>
           <p:cNvSpPr/>
           <p:nvPr/>
         </p:nvSpPr>
@@ -5515,7 +5632,7 @@
       </p:sp>
       <p:sp>
         <p:nvSpPr>
-          <p:cNvPr id="5" name="Text 3"/>
+          <p:cNvPr id="6" name="Text 4"/>
           <p:cNvSpPr txBox="1"/>
           <p:nvPr/>
         </p:nvSpPr>
@@ -5554,7 +5671,7 @@
       </p:sp>
       <p:sp>
         <p:nvSpPr>
-          <p:cNvPr id="6" name="Text 4"/>
+          <p:cNvPr id="7" name="Text 5"/>
           <p:cNvSpPr txBox="1"/>
           <p:nvPr/>
         </p:nvSpPr>
@@ -5593,7 +5710,7 @@
       </p:sp>
       <p:sp>
         <p:nvSpPr>
-          <p:cNvPr id="7" name="Text 5"/>
+          <p:cNvPr id="8" name="Text 6"/>
           <p:cNvSpPr txBox="1"/>
           <p:nvPr/>
         </p:nvSpPr>
@@ -5635,7 +5752,7 @@
       </p:sp>
       <p:sp>
         <p:nvSpPr>
-          <p:cNvPr id="8" name="Shape 6"/>
+          <p:cNvPr id="9" name="Shape 7"/>
           <p:cNvSpPr/>
           <p:nvPr/>
         </p:nvSpPr>
@@ -5662,7 +5779,7 @@
       </p:sp>
       <p:sp>
         <p:nvSpPr>
-          <p:cNvPr id="9" name="Text 7"/>
+          <p:cNvPr id="10" name="Text 8"/>
           <p:cNvSpPr txBox="1"/>
           <p:nvPr/>
         </p:nvSpPr>
@@ -5701,7 +5818,7 @@
       </p:sp>
       <p:sp>
         <p:nvSpPr>
-          <p:cNvPr id="10" name="Text 8"/>
+          <p:cNvPr id="11" name="Text 9"/>
           <p:cNvSpPr txBox="1"/>
           <p:nvPr/>
         </p:nvSpPr>
@@ -5740,7 +5857,7 @@
       </p:sp>
       <p:sp>
         <p:nvSpPr>
-          <p:cNvPr id="11" name="Text 9"/>
+          <p:cNvPr id="12" name="Text 10"/>
           <p:cNvSpPr txBox="1"/>
           <p:nvPr/>
         </p:nvSpPr>
@@ -5782,7 +5899,7 @@
       </p:sp>
       <p:sp>
         <p:nvSpPr>
-          <p:cNvPr id="12" name="Shape 10"/>
+          <p:cNvPr id="13" name="Shape 11"/>
           <p:cNvSpPr/>
           <p:nvPr/>
         </p:nvSpPr>
@@ -5809,7 +5926,7 @@
       </p:sp>
       <p:sp>
         <p:nvSpPr>
-          <p:cNvPr id="13" name="Text 11"/>
+          <p:cNvPr id="14" name="Text 12"/>
           <p:cNvSpPr txBox="1"/>
           <p:nvPr/>
         </p:nvSpPr>
@@ -5848,7 +5965,7 @@
       </p:sp>
       <p:sp>
         <p:nvSpPr>
-          <p:cNvPr id="14" name="Text 12"/>
+          <p:cNvPr id="15" name="Text 13"/>
           <p:cNvSpPr txBox="1"/>
           <p:nvPr/>
         </p:nvSpPr>
@@ -5887,7 +6004,7 @@
       </p:sp>
       <p:sp>
         <p:nvSpPr>
-          <p:cNvPr id="15" name="Text 13"/>
+          <p:cNvPr id="16" name="Text 14"/>
           <p:cNvSpPr txBox="1"/>
           <p:nvPr/>
         </p:nvSpPr>
@@ -5929,7 +6046,7 @@
       </p:sp>
       <p:sp>
         <p:nvSpPr>
-          <p:cNvPr id="16" name="Shape 14"/>
+          <p:cNvPr id="17" name="Shape 15"/>
           <p:cNvSpPr/>
           <p:nvPr/>
         </p:nvSpPr>
@@ -5956,7 +6073,7 @@
       </p:sp>
       <p:sp>
         <p:nvSpPr>
-          <p:cNvPr id="17" name="Text 15"/>
+          <p:cNvPr id="18" name="Text 16"/>
           <p:cNvSpPr txBox="1"/>
           <p:nvPr/>
         </p:nvSpPr>
@@ -5995,7 +6112,7 @@
       </p:sp>
       <p:sp>
         <p:nvSpPr>
-          <p:cNvPr id="18" name="Text 16"/>
+          <p:cNvPr id="19" name="Text 17"/>
           <p:cNvSpPr txBox="1"/>
           <p:nvPr/>
         </p:nvSpPr>
@@ -6034,7 +6151,7 @@
       </p:sp>
       <p:sp>
         <p:nvSpPr>
-          <p:cNvPr id="19" name="Text 17"/>
+          <p:cNvPr id="20" name="Text 18"/>
           <p:cNvSpPr txBox="1"/>
           <p:nvPr/>
         </p:nvSpPr>
@@ -6076,7 +6193,7 @@
       </p:sp>
       <p:sp>
         <p:nvSpPr>
-          <p:cNvPr id="20" name="Shape 18"/>
+          <p:cNvPr id="21" name="Shape 19"/>
           <p:cNvSpPr/>
           <p:nvPr/>
         </p:nvSpPr>
@@ -6103,7 +6220,7 @@
       </p:sp>
       <p:sp>
         <p:nvSpPr>
-          <p:cNvPr id="21" name="Text 19"/>
+          <p:cNvPr id="22" name="Text 20"/>
           <p:cNvSpPr txBox="1"/>
           <p:nvPr/>
         </p:nvSpPr>
@@ -6142,7 +6259,7 @@
       </p:sp>
       <p:sp>
         <p:nvSpPr>
-          <p:cNvPr id="22" name="Text 20"/>
+          <p:cNvPr id="23" name="Text 21"/>
           <p:cNvSpPr txBox="1"/>
           <p:nvPr/>
         </p:nvSpPr>
@@ -6181,7 +6298,7 @@
       </p:sp>
       <p:sp>
         <p:nvSpPr>
-          <p:cNvPr id="23" name="Text 21"/>
+          <p:cNvPr id="24" name="Text 22"/>
           <p:cNvSpPr txBox="1"/>
           <p:nvPr/>
         </p:nvSpPr>
@@ -6223,7 +6340,7 @@
       </p:sp>
       <p:sp>
         <p:nvSpPr>
-          <p:cNvPr id="24" name="Shape 22"/>
+          <p:cNvPr id="25" name="Shape 23"/>
           <p:cNvSpPr/>
           <p:nvPr/>
         </p:nvSpPr>
@@ -6250,7 +6367,7 @@
       </p:sp>
       <p:sp>
         <p:nvSpPr>
-          <p:cNvPr id="25" name="Text 23"/>
+          <p:cNvPr id="26" name="Text 24"/>
           <p:cNvSpPr txBox="1"/>
           <p:nvPr/>
         </p:nvSpPr>
@@ -6289,7 +6406,7 @@
       </p:sp>
       <p:sp>
         <p:nvSpPr>
-          <p:cNvPr id="26" name="Text 24"/>
+          <p:cNvPr id="27" name="Text 25"/>
           <p:cNvSpPr txBox="1"/>
           <p:nvPr/>
         </p:nvSpPr>
@@ -6328,7 +6445,7 @@
       </p:sp>
       <p:sp>
         <p:nvSpPr>
-          <p:cNvPr id="27" name="Text 25"/>
+          <p:cNvPr id="28" name="Text 26"/>
           <p:cNvSpPr txBox="1"/>
           <p:nvPr/>
         </p:nvSpPr>
@@ -6370,7 +6487,7 @@
       </p:sp>
       <p:sp>
         <p:nvSpPr>
-          <p:cNvPr id="28" name="Shape 26"/>
+          <p:cNvPr id="29" name="Shape 27"/>
           <p:cNvSpPr/>
           <p:nvPr/>
         </p:nvSpPr>
@@ -6397,7 +6514,7 @@
       </p:sp>
       <p:sp>
         <p:nvSpPr>
-          <p:cNvPr id="29" name="Text 27"/>
+          <p:cNvPr id="30" name="Text 28"/>
           <p:cNvSpPr txBox="1"/>
           <p:nvPr/>
         </p:nvSpPr>
@@ -6436,7 +6553,7 @@
       </p:sp>
       <p:sp>
         <p:nvSpPr>
-          <p:cNvPr id="30" name="Text 28"/>
+          <p:cNvPr id="31" name="Text 29"/>
           <p:cNvSpPr txBox="1"/>
           <p:nvPr/>
         </p:nvSpPr>
@@ -6475,7 +6592,7 @@
       </p:sp>
       <p:sp>
         <p:nvSpPr>
-          <p:cNvPr id="31" name="Text 29"/>
+          <p:cNvPr id="32" name="Text 30"/>
           <p:cNvSpPr txBox="1"/>
           <p:nvPr/>
         </p:nvSpPr>
@@ -6517,7 +6634,7 @@
       </p:sp>
       <p:sp>
         <p:nvSpPr>
-          <p:cNvPr id="32" name="Shape 30"/>
+          <p:cNvPr id="33" name="Shape 31"/>
           <p:cNvSpPr/>
           <p:nvPr/>
         </p:nvSpPr>
@@ -6544,7 +6661,7 @@
       </p:sp>
       <p:sp>
         <p:nvSpPr>
-          <p:cNvPr id="33" name="Text 31"/>
+          <p:cNvPr id="34" name="Text 32"/>
           <p:cNvSpPr txBox="1"/>
           <p:nvPr/>
         </p:nvSpPr>
@@ -6601,45 +6718,6 @@
               <a:t>A pass earns a reading — not a purchase.</a:t>
             </a:r>
             <a:endParaRPr lang="en-US" sz="1350" dirty="0"/>
-          </a:p>
-        </p:txBody>
-      </p:sp>
-      <p:sp>
-        <p:nvSpPr>
-          <p:cNvPr id="34" name="Text 32"/>
-          <p:cNvSpPr txBox="1"/>
-          <p:nvPr/>
-        </p:nvSpPr>
-        <p:spPr>
-          <a:xfrm>
-            <a:off x="548640" y="6419088"/>
-            <a:ext cx="3108960" cy="274320"/>
-          </a:xfrm>
-          <a:prstGeom prst="rect">
-            <a:avLst/>
-          </a:prstGeom>
-          <a:noFill/>
-          <a:ln/>
-        </p:spPr>
-        <p:txBody>
-          <a:bodyPr wrap="square" lIns="0" tIns="0" rIns="0" bIns="0" rtlCol="0" anchor="ctr"/>
-          <a:lstStyle/>
-          <a:p>
-            <a:pPr indent="0" marL="0">
-              <a:buNone/>
-            </a:pPr>
-            <a:r>
-              <a:rPr lang="en-US" sz="900" dirty="0">
-                <a:solidFill>
-                  <a:srgbClr val="6B7A72"/>
-                </a:solidFill>
-                <a:latin typeface="Calibri" pitchFamily="34" charset="0"/>
-                <a:ea typeface="Calibri" pitchFamily="34" charset="-122"/>
-                <a:cs typeface="Calibri" pitchFamily="34" charset="-120"/>
-              </a:rPr>
-              <a:t>Education, not advice.</a:t>
-            </a:r>
-            <a:endParaRPr lang="en-US" sz="900" dirty="0"/>
           </a:p>
         </p:txBody>
       </p:sp>
@@ -6722,6 +6800,45 @@
         </p:nvSpPr>
         <p:spPr>
           <a:xfrm>
+            <a:off x="548640" y="6419088"/>
+            <a:ext cx="3108960" cy="274320"/>
+          </a:xfrm>
+          <a:prstGeom prst="rect">
+            <a:avLst/>
+          </a:prstGeom>
+          <a:noFill/>
+          <a:ln/>
+        </p:spPr>
+        <p:txBody>
+          <a:bodyPr wrap="square" lIns="0" tIns="0" rIns="0" bIns="0" rtlCol="0" anchor="ctr"/>
+          <a:lstStyle/>
+          <a:p>
+            <a:pPr indent="0" marL="0">
+              <a:buNone/>
+            </a:pPr>
+            <a:r>
+              <a:rPr lang="en-US" sz="900" dirty="0">
+                <a:solidFill>
+                  <a:srgbClr val="6B7A72"/>
+                </a:solidFill>
+                <a:latin typeface="Calibri" pitchFamily="34" charset="0"/>
+                <a:ea typeface="Calibri" pitchFamily="34" charset="-122"/>
+                <a:cs typeface="Calibri" pitchFamily="34" charset="-120"/>
+              </a:rPr>
+              <a:t>Education, not advice.</a:t>
+            </a:r>
+            <a:endParaRPr lang="en-US" sz="900" dirty="0"/>
+          </a:p>
+        </p:txBody>
+      </p:sp>
+      <p:sp>
+        <p:nvSpPr>
+          <p:cNvPr id="3" name="Text 1"/>
+          <p:cNvSpPr txBox="1"/>
+          <p:nvPr/>
+        </p:nvSpPr>
+        <p:spPr>
+          <a:xfrm>
             <a:off x="822960" y="502920"/>
             <a:ext cx="9144000" cy="320040"/>
           </a:xfrm>
@@ -6755,7 +6872,7 @@
       </p:sp>
       <p:sp>
         <p:nvSpPr>
-          <p:cNvPr id="3" name="Text 1"/>
+          <p:cNvPr id="4" name="Text 2"/>
           <p:cNvSpPr txBox="1"/>
           <p:nvPr/>
         </p:nvSpPr>
@@ -6794,7 +6911,7 @@
       </p:sp>
       <p:sp>
         <p:nvSpPr>
-          <p:cNvPr id="4" name="Text 2"/>
+          <p:cNvPr id="5" name="Text 3"/>
           <p:cNvSpPr txBox="1"/>
           <p:nvPr/>
         </p:nvSpPr>
@@ -8239,7 +8356,7 @@
       </p:graphicFrame>
       <p:sp>
         <p:nvSpPr>
-          <p:cNvPr id="6" name="Text 3"/>
+          <p:cNvPr id="7" name="Text 4"/>
           <p:cNvSpPr txBox="1"/>
           <p:nvPr/>
         </p:nvSpPr>
@@ -8276,45 +8393,6 @@
               <a:t>Honest data use means saying where your data runs short. A tip-seller's spreadsheet never tells you where its numbers ran out.</a:t>
             </a:r>
             <a:endParaRPr lang="en-US" sz="1800" dirty="0"/>
-          </a:p>
-        </p:txBody>
-      </p:sp>
-      <p:sp>
-        <p:nvSpPr>
-          <p:cNvPr id="7" name="Text 4"/>
-          <p:cNvSpPr txBox="1"/>
-          <p:nvPr/>
-        </p:nvSpPr>
-        <p:spPr>
-          <a:xfrm>
-            <a:off x="548640" y="6419088"/>
-            <a:ext cx="3108960" cy="274320"/>
-          </a:xfrm>
-          <a:prstGeom prst="rect">
-            <a:avLst/>
-          </a:prstGeom>
-          <a:noFill/>
-          <a:ln/>
-        </p:spPr>
-        <p:txBody>
-          <a:bodyPr wrap="square" lIns="0" tIns="0" rIns="0" bIns="0" rtlCol="0" anchor="ctr"/>
-          <a:lstStyle/>
-          <a:p>
-            <a:pPr indent="0" marL="0">
-              <a:buNone/>
-            </a:pPr>
-            <a:r>
-              <a:rPr lang="en-US" sz="900" dirty="0">
-                <a:solidFill>
-                  <a:srgbClr val="6B7A72"/>
-                </a:solidFill>
-                <a:latin typeface="Calibri" pitchFamily="34" charset="0"/>
-                <a:ea typeface="Calibri" pitchFamily="34" charset="-122"/>
-                <a:cs typeface="Calibri" pitchFamily="34" charset="-120"/>
-              </a:rPr>
-              <a:t>Education, not advice.</a:t>
-            </a:r>
-            <a:endParaRPr lang="en-US" sz="900" dirty="0"/>
           </a:p>
         </p:txBody>
       </p:sp>
@@ -8358,6 +8436,45 @@
         </p:nvSpPr>
         <p:spPr>
           <a:xfrm>
+            <a:off x="548640" y="6419088"/>
+            <a:ext cx="3108960" cy="274320"/>
+          </a:xfrm>
+          <a:prstGeom prst="rect">
+            <a:avLst/>
+          </a:prstGeom>
+          <a:noFill/>
+          <a:ln/>
+        </p:spPr>
+        <p:txBody>
+          <a:bodyPr wrap="square" lIns="0" tIns="0" rIns="0" bIns="0" rtlCol="0" anchor="ctr"/>
+          <a:lstStyle/>
+          <a:p>
+            <a:pPr indent="0" marL="0">
+              <a:buNone/>
+            </a:pPr>
+            <a:r>
+              <a:rPr lang="en-US" sz="900" dirty="0">
+                <a:solidFill>
+                  <a:srgbClr val="6B7A72"/>
+                </a:solidFill>
+                <a:latin typeface="Calibri" pitchFamily="34" charset="0"/>
+                <a:ea typeface="Calibri" pitchFamily="34" charset="-122"/>
+                <a:cs typeface="Calibri" pitchFamily="34" charset="-120"/>
+              </a:rPr>
+              <a:t>Education, not advice.</a:t>
+            </a:r>
+            <a:endParaRPr lang="en-US" sz="900" dirty="0"/>
+          </a:p>
+        </p:txBody>
+      </p:sp>
+      <p:sp>
+        <p:nvSpPr>
+          <p:cNvPr id="3" name="Text 1"/>
+          <p:cNvSpPr txBox="1"/>
+          <p:nvPr/>
+        </p:nvSpPr>
+        <p:spPr>
+          <a:xfrm>
             <a:off x="822960" y="502920"/>
             <a:ext cx="9144000" cy="320040"/>
           </a:xfrm>
@@ -8391,7 +8508,7 @@
       </p:sp>
       <p:sp>
         <p:nvSpPr>
-          <p:cNvPr id="3" name="Text 1"/>
+          <p:cNvPr id="4" name="Text 2"/>
           <p:cNvSpPr txBox="1"/>
           <p:nvPr/>
         </p:nvSpPr>
@@ -8430,7 +8547,7 @@
       </p:sp>
       <p:sp>
         <p:nvSpPr>
-          <p:cNvPr id="4" name="Text 2"/>
+          <p:cNvPr id="5" name="Text 3"/>
           <p:cNvSpPr txBox="1"/>
           <p:nvPr/>
         </p:nvSpPr>
@@ -8473,7 +8590,7 @@
       </p:sp>
       <p:sp>
         <p:nvSpPr>
-          <p:cNvPr id="5" name="Text 3"/>
+          <p:cNvPr id="6" name="Text 4"/>
           <p:cNvSpPr txBox="1"/>
           <p:nvPr/>
         </p:nvSpPr>
@@ -8550,7 +8667,7 @@
       </p:sp>
       <p:sp>
         <p:nvSpPr>
-          <p:cNvPr id="6" name="Text 4"/>
+          <p:cNvPr id="7" name="Text 5"/>
           <p:cNvSpPr txBox="1"/>
           <p:nvPr/>
         </p:nvSpPr>
@@ -8584,45 +8701,6 @@
               <a:t>A decision written down before the outcome — the only kind we can grade.</a:t>
             </a:r>
             <a:endParaRPr lang="en-US" sz="1900" dirty="0"/>
-          </a:p>
-        </p:txBody>
-      </p:sp>
-      <p:sp>
-        <p:nvSpPr>
-          <p:cNvPr id="7" name="Text 5"/>
-          <p:cNvSpPr txBox="1"/>
-          <p:nvPr/>
-        </p:nvSpPr>
-        <p:spPr>
-          <a:xfrm>
-            <a:off x="548640" y="6419088"/>
-            <a:ext cx="3108960" cy="274320"/>
-          </a:xfrm>
-          <a:prstGeom prst="rect">
-            <a:avLst/>
-          </a:prstGeom>
-          <a:noFill/>
-          <a:ln/>
-        </p:spPr>
-        <p:txBody>
-          <a:bodyPr wrap="square" lIns="0" tIns="0" rIns="0" bIns="0" rtlCol="0" anchor="ctr"/>
-          <a:lstStyle/>
-          <a:p>
-            <a:pPr indent="0" marL="0">
-              <a:buNone/>
-            </a:pPr>
-            <a:r>
-              <a:rPr lang="en-US" sz="900" dirty="0">
-                <a:solidFill>
-                  <a:srgbClr val="6B7A72"/>
-                </a:solidFill>
-                <a:latin typeface="Calibri" pitchFamily="34" charset="0"/>
-                <a:ea typeface="Calibri" pitchFamily="34" charset="-122"/>
-                <a:cs typeface="Calibri" pitchFamily="34" charset="-120"/>
-              </a:rPr>
-              <a:t>Education, not advice.</a:t>
-            </a:r>
-            <a:endParaRPr lang="en-US" sz="900" dirty="0"/>
           </a:p>
         </p:txBody>
       </p:sp>
@@ -8666,6 +8744,45 @@
         </p:nvSpPr>
         <p:spPr>
           <a:xfrm>
+            <a:off x="548640" y="6419088"/>
+            <a:ext cx="3108960" cy="274320"/>
+          </a:xfrm>
+          <a:prstGeom prst="rect">
+            <a:avLst/>
+          </a:prstGeom>
+          <a:noFill/>
+          <a:ln/>
+        </p:spPr>
+        <p:txBody>
+          <a:bodyPr wrap="square" lIns="0" tIns="0" rIns="0" bIns="0" rtlCol="0" anchor="ctr"/>
+          <a:lstStyle/>
+          <a:p>
+            <a:pPr indent="0" marL="0">
+              <a:buNone/>
+            </a:pPr>
+            <a:r>
+              <a:rPr lang="en-US" sz="900" dirty="0">
+                <a:solidFill>
+                  <a:srgbClr val="A9B6AE"/>
+                </a:solidFill>
+                <a:latin typeface="Calibri" pitchFamily="34" charset="0"/>
+                <a:ea typeface="Calibri" pitchFamily="34" charset="-122"/>
+                <a:cs typeface="Calibri" pitchFamily="34" charset="-120"/>
+              </a:rPr>
+              <a:t>Education, not advice.</a:t>
+            </a:r>
+            <a:endParaRPr lang="en-US" sz="900" dirty="0"/>
+          </a:p>
+        </p:txBody>
+      </p:sp>
+      <p:sp>
+        <p:nvSpPr>
+          <p:cNvPr id="3" name="Text 1"/>
+          <p:cNvSpPr txBox="1"/>
+          <p:nvPr/>
+        </p:nvSpPr>
+        <p:spPr>
+          <a:xfrm>
             <a:off x="822960" y="731520"/>
             <a:ext cx="9144000" cy="365760"/>
           </a:xfrm>
@@ -8699,7 +8816,7 @@
       </p:sp>
       <p:sp>
         <p:nvSpPr>
-          <p:cNvPr id="3" name="Text 1"/>
+          <p:cNvPr id="4" name="Text 2"/>
           <p:cNvSpPr txBox="1"/>
           <p:nvPr/>
         </p:nvSpPr>
@@ -8738,7 +8855,7 @@
       </p:sp>
       <p:sp>
         <p:nvSpPr>
-          <p:cNvPr id="4" name="Shape 2"/>
+          <p:cNvPr id="5" name="Shape 3"/>
           <p:cNvSpPr/>
           <p:nvPr/>
         </p:nvSpPr>
@@ -8765,7 +8882,7 @@
       </p:sp>
       <p:sp>
         <p:nvSpPr>
-          <p:cNvPr id="5" name="Text 3"/>
+          <p:cNvPr id="6" name="Text 4"/>
           <p:cNvSpPr txBox="1"/>
           <p:nvPr/>
         </p:nvSpPr>
@@ -8804,7 +8921,7 @@
       </p:sp>
       <p:sp>
         <p:nvSpPr>
-          <p:cNvPr id="6" name="Text 4"/>
+          <p:cNvPr id="7" name="Text 5"/>
           <p:cNvSpPr txBox="1"/>
           <p:nvPr/>
         </p:nvSpPr>
@@ -8881,7 +8998,7 @@
       </p:sp>
       <p:sp>
         <p:nvSpPr>
-          <p:cNvPr id="7" name="Text 5"/>
+          <p:cNvPr id="8" name="Text 6"/>
           <p:cNvSpPr txBox="1"/>
           <p:nvPr/>
         </p:nvSpPr>
@@ -8958,6 +9075,45 @@
         </p:nvSpPr>
         <p:spPr>
           <a:xfrm>
+            <a:off x="548640" y="6419088"/>
+            <a:ext cx="3108960" cy="274320"/>
+          </a:xfrm>
+          <a:prstGeom prst="rect">
+            <a:avLst/>
+          </a:prstGeom>
+          <a:noFill/>
+          <a:ln/>
+        </p:spPr>
+        <p:txBody>
+          <a:bodyPr wrap="square" lIns="0" tIns="0" rIns="0" bIns="0" rtlCol="0" anchor="ctr"/>
+          <a:lstStyle/>
+          <a:p>
+            <a:pPr indent="0" marL="0">
+              <a:buNone/>
+            </a:pPr>
+            <a:r>
+              <a:rPr lang="en-US" sz="900" dirty="0">
+                <a:solidFill>
+                  <a:srgbClr val="6B7A72"/>
+                </a:solidFill>
+                <a:latin typeface="Calibri" pitchFamily="34" charset="0"/>
+                <a:ea typeface="Calibri" pitchFamily="34" charset="-122"/>
+                <a:cs typeface="Calibri" pitchFamily="34" charset="-120"/>
+              </a:rPr>
+              <a:t>Education, not advice.</a:t>
+            </a:r>
+            <a:endParaRPr lang="en-US" sz="900" dirty="0"/>
+          </a:p>
+        </p:txBody>
+      </p:sp>
+      <p:sp>
+        <p:nvSpPr>
+          <p:cNvPr id="3" name="Text 1"/>
+          <p:cNvSpPr txBox="1"/>
+          <p:nvPr/>
+        </p:nvSpPr>
+        <p:spPr>
+          <a:xfrm>
             <a:off x="1097280" y="1737360"/>
             <a:ext cx="9966960" cy="2377440"/>
           </a:xfrm>
@@ -8994,7 +9150,7 @@
       </p:sp>
       <p:sp>
         <p:nvSpPr>
-          <p:cNvPr id="3" name="Text 1"/>
+          <p:cNvPr id="4" name="Text 2"/>
           <p:cNvSpPr txBox="1"/>
           <p:nvPr/>
         </p:nvSpPr>
@@ -9051,45 +9207,6 @@
               <a:t>Graham's own screen passed just 5 of the 30 Dow stocks in 1970 — and two of the five, Anaconda and Woolworth, went badly within years. Passing earns a reading, not safety.</a:t>
             </a:r>
             <a:endParaRPr lang="en-US" sz="1600" dirty="0"/>
-          </a:p>
-        </p:txBody>
-      </p:sp>
-      <p:sp>
-        <p:nvSpPr>
-          <p:cNvPr id="4" name="Text 2"/>
-          <p:cNvSpPr txBox="1"/>
-          <p:nvPr/>
-        </p:nvSpPr>
-        <p:spPr>
-          <a:xfrm>
-            <a:off x="548640" y="6419088"/>
-            <a:ext cx="3108960" cy="274320"/>
-          </a:xfrm>
-          <a:prstGeom prst="rect">
-            <a:avLst/>
-          </a:prstGeom>
-          <a:noFill/>
-          <a:ln/>
-        </p:spPr>
-        <p:txBody>
-          <a:bodyPr wrap="square" lIns="0" tIns="0" rIns="0" bIns="0" rtlCol="0" anchor="ctr"/>
-          <a:lstStyle/>
-          <a:p>
-            <a:pPr indent="0" marL="0">
-              <a:buNone/>
-            </a:pPr>
-            <a:r>
-              <a:rPr lang="en-US" sz="900" dirty="0">
-                <a:solidFill>
-                  <a:srgbClr val="6B7A72"/>
-                </a:solidFill>
-                <a:latin typeface="Calibri" pitchFamily="34" charset="0"/>
-                <a:ea typeface="Calibri" pitchFamily="34" charset="-122"/>
-                <a:cs typeface="Calibri" pitchFamily="34" charset="-120"/>
-              </a:rPr>
-              <a:t>Education, not advice.</a:t>
-            </a:r>
-            <a:endParaRPr lang="en-US" sz="900" dirty="0"/>
           </a:p>
         </p:txBody>
       </p:sp>
@@ -9172,6 +9289,45 @@
         </p:nvSpPr>
         <p:spPr>
           <a:xfrm>
+            <a:off x="548640" y="6419088"/>
+            <a:ext cx="3108960" cy="274320"/>
+          </a:xfrm>
+          <a:prstGeom prst="rect">
+            <a:avLst/>
+          </a:prstGeom>
+          <a:noFill/>
+          <a:ln/>
+        </p:spPr>
+        <p:txBody>
+          <a:bodyPr wrap="square" lIns="0" tIns="0" rIns="0" bIns="0" rtlCol="0" anchor="ctr"/>
+          <a:lstStyle/>
+          <a:p>
+            <a:pPr indent="0" marL="0">
+              <a:buNone/>
+            </a:pPr>
+            <a:r>
+              <a:rPr lang="en-US" sz="900" dirty="0">
+                <a:solidFill>
+                  <a:srgbClr val="6B7A72"/>
+                </a:solidFill>
+                <a:latin typeface="Calibri" pitchFamily="34" charset="0"/>
+                <a:ea typeface="Calibri" pitchFamily="34" charset="-122"/>
+                <a:cs typeface="Calibri" pitchFamily="34" charset="-120"/>
+              </a:rPr>
+              <a:t>Education, not advice.</a:t>
+            </a:r>
+            <a:endParaRPr lang="en-US" sz="900" dirty="0"/>
+          </a:p>
+        </p:txBody>
+      </p:sp>
+      <p:sp>
+        <p:nvSpPr>
+          <p:cNvPr id="3" name="Text 1"/>
+          <p:cNvSpPr txBox="1"/>
+          <p:nvPr/>
+        </p:nvSpPr>
+        <p:spPr>
+          <a:xfrm>
             <a:off x="822960" y="502920"/>
             <a:ext cx="9144000" cy="320040"/>
           </a:xfrm>
@@ -9205,7 +9361,7 @@
       </p:sp>
       <p:sp>
         <p:nvSpPr>
-          <p:cNvPr id="3" name="Text 1"/>
+          <p:cNvPr id="4" name="Text 2"/>
           <p:cNvSpPr txBox="1"/>
           <p:nvPr/>
         </p:nvSpPr>
@@ -9244,7 +9400,7 @@
       </p:sp>
       <p:sp>
         <p:nvSpPr>
-          <p:cNvPr id="4" name="Shape 2"/>
+          <p:cNvPr id="5" name="Shape 3"/>
           <p:cNvSpPr/>
           <p:nvPr/>
         </p:nvSpPr>
@@ -9278,7 +9434,7 @@
       </p:sp>
       <p:sp>
         <p:nvSpPr>
-          <p:cNvPr id="5" name="Text 3"/>
+          <p:cNvPr id="6" name="Text 4"/>
           <p:cNvSpPr txBox="1"/>
           <p:nvPr/>
         </p:nvSpPr>
@@ -9317,7 +9473,7 @@
       </p:sp>
       <p:sp>
         <p:nvSpPr>
-          <p:cNvPr id="6" name="Text 4"/>
+          <p:cNvPr id="7" name="Text 5"/>
           <p:cNvSpPr txBox="1"/>
           <p:nvPr/>
         </p:nvSpPr>
@@ -9359,7 +9515,7 @@
       </p:sp>
       <p:sp>
         <p:nvSpPr>
-          <p:cNvPr id="7" name="Shape 5"/>
+          <p:cNvPr id="8" name="Shape 6"/>
           <p:cNvSpPr/>
           <p:nvPr/>
         </p:nvSpPr>
@@ -9393,7 +9549,7 @@
       </p:sp>
       <p:sp>
         <p:nvSpPr>
-          <p:cNvPr id="8" name="Text 6"/>
+          <p:cNvPr id="9" name="Text 7"/>
           <p:cNvSpPr txBox="1"/>
           <p:nvPr/>
         </p:nvSpPr>
@@ -9432,7 +9588,7 @@
       </p:sp>
       <p:sp>
         <p:nvSpPr>
-          <p:cNvPr id="9" name="Text 7"/>
+          <p:cNvPr id="10" name="Text 8"/>
           <p:cNvSpPr txBox="1"/>
           <p:nvPr/>
         </p:nvSpPr>
@@ -9474,7 +9630,7 @@
       </p:sp>
       <p:sp>
         <p:nvSpPr>
-          <p:cNvPr id="10" name="Shape 8"/>
+          <p:cNvPr id="11" name="Shape 9"/>
           <p:cNvSpPr/>
           <p:nvPr/>
         </p:nvSpPr>
@@ -9508,7 +9664,7 @@
       </p:sp>
       <p:sp>
         <p:nvSpPr>
-          <p:cNvPr id="11" name="Text 9"/>
+          <p:cNvPr id="12" name="Text 10"/>
           <p:cNvSpPr txBox="1"/>
           <p:nvPr/>
         </p:nvSpPr>
@@ -9547,7 +9703,7 @@
       </p:sp>
       <p:sp>
         <p:nvSpPr>
-          <p:cNvPr id="12" name="Text 10"/>
+          <p:cNvPr id="13" name="Text 11"/>
           <p:cNvSpPr txBox="1"/>
           <p:nvPr/>
         </p:nvSpPr>
@@ -9589,7 +9745,7 @@
       </p:sp>
       <p:sp>
         <p:nvSpPr>
-          <p:cNvPr id="13" name="Text 11"/>
+          <p:cNvPr id="14" name="Text 12"/>
           <p:cNvSpPr txBox="1"/>
           <p:nvPr/>
         </p:nvSpPr>
@@ -9623,45 +9779,6 @@
               <a:t>Each pair takes the best scorer on the screen — a survivor, a near miss, or if none, the highest score — plus one famous failure. One sentence per pair; the course takes no side.</a:t>
             </a:r>
             <a:endParaRPr lang="en-US" sz="1600" dirty="0"/>
-          </a:p>
-        </p:txBody>
-      </p:sp>
-      <p:sp>
-        <p:nvSpPr>
-          <p:cNvPr id="14" name="Text 12"/>
-          <p:cNvSpPr txBox="1"/>
-          <p:nvPr/>
-        </p:nvSpPr>
-        <p:spPr>
-          <a:xfrm>
-            <a:off x="548640" y="6419088"/>
-            <a:ext cx="3108960" cy="274320"/>
-          </a:xfrm>
-          <a:prstGeom prst="rect">
-            <a:avLst/>
-          </a:prstGeom>
-          <a:noFill/>
-          <a:ln/>
-        </p:spPr>
-        <p:txBody>
-          <a:bodyPr wrap="square" lIns="0" tIns="0" rIns="0" bIns="0" rtlCol="0" anchor="ctr"/>
-          <a:lstStyle/>
-          <a:p>
-            <a:pPr indent="0" marL="0">
-              <a:buNone/>
-            </a:pPr>
-            <a:r>
-              <a:rPr lang="en-US" sz="900" dirty="0">
-                <a:solidFill>
-                  <a:srgbClr val="6B7A72"/>
-                </a:solidFill>
-                <a:latin typeface="Calibri" pitchFamily="34" charset="0"/>
-                <a:ea typeface="Calibri" pitchFamily="34" charset="-122"/>
-                <a:cs typeface="Calibri" pitchFamily="34" charset="-120"/>
-              </a:rPr>
-              <a:t>Education, not advice.</a:t>
-            </a:r>
-            <a:endParaRPr lang="en-US" sz="900" dirty="0"/>
           </a:p>
         </p:txBody>
       </p:sp>

</xml_diff>